<commit_message>
Publish Lab02 deck and forty-minute inventory example
</commit_message>
<xml_diff>
--- a/labs/Lab02/slides.pptx
+++ b/labs/Lab02/slides.pptx
@@ -13,9 +13,13 @@
     <p:sldId id="261" r:id="rId7"/>
     <p:sldId id="262" r:id="rId8"/>
     <p:sldId id="263" r:id="rId9"/>
+    <p:sldId id="264" r:id="rId10"/>
+    <p:sldId id="265" r:id="rId11"/>
+    <p:sldId id="266" r:id="rId12"/>
+    <p:sldId id="267" r:id="rId13"/>
   </p:sldIdLst>
   <p:notesMasterIdLst>
-    <p:notesMasterId r:id="rId10"/>
+    <p:notesMasterId r:id="rId14"/>
   </p:notesMasterIdLst>
   <p:sldSz cx="9334500" cy="5248275"/>
   <p:notesSz cx="5248275" cy="9334500"/>
@@ -509,7 +513,7 @@
           <a:p>
             <a:r>
               <a:rPr lang="en-US" dirty="0"/>
-              <a:t>Set a concrete goal for the work block. No new application or separate lab grade.</a:t>
+              <a:t>Introduce the stockroom example. This is guided design and one implementation increment, not a full build from scratch. No lab deliverable.</a:t>
             </a:r>
             <a:endParaRPr lang="en-US" dirty="0"/>
           </a:p>
@@ -551,6 +555,270 @@
 </p:notes>
 </file>
 
+<file path=ppt/notesSlides/notesSlide10.xml><?xml version="1.0" encoding="utf-8"?>
+<p:notes xmlns:a="http://schemas.openxmlformats.org/drawingml/2006/main" xmlns:r="http://schemas.openxmlformats.org/officeDocument/2006/relationships" xmlns:p="http://schemas.openxmlformats.org/presentationml/2006/main">
+  <p:cSld>
+    <p:spTree>
+      <p:nvGrpSpPr>
+        <p:cNvPr id="1" name=""/>
+        <p:cNvGrpSpPr/>
+        <p:nvPr/>
+      </p:nvGrpSpPr>
+      <p:grpSpPr>
+        <a:xfrm>
+          <a:off x="0" y="0"/>
+          <a:ext cx="0" cy="0"/>
+          <a:chOff x="0" y="0"/>
+          <a:chExt cx="0" cy="0"/>
+        </a:xfrm>
+      </p:grpSpPr>
+      <p:sp>
+        <p:nvSpPr>
+          <p:cNvPr id="2" name="Slide Image Placeholder 1"/>
+          <p:cNvSpPr>
+            <a:spLocks noGrp="1" noRot="1" noChangeAspect="1"/>
+          </p:cNvSpPr>
+          <p:nvPr>
+            <p:ph type="sldImg"/>
+          </p:nvPr>
+        </p:nvSpPr>
+        <p:spPr/>
+      </p:sp>
+      <p:sp>
+        <p:nvSpPr>
+          <p:cNvPr id="3" name="Notes Placeholder 2"/>
+          <p:cNvSpPr>
+            <a:spLocks noGrp="1"/>
+          </p:cNvSpPr>
+          <p:nvPr>
+            <p:ph type="body" idx="1"/>
+          </p:nvPr>
+        </p:nvSpPr>
+        <p:spPr/>
+        <p:txBody>
+          <a:bodyPr/>
+          <a:lstStyle/>
+          <a:p>
+            <a:r>
+              <a:rPr lang="en-US" dirty="0"/>
+              <a:t>Minutes 36–40. Open REFLECTION.md. Explain that design quality and meaningful behavior matter more than counts of tools, calls or agents. The sample honestly names model-authored final reports and approval timing as limitations. The actual prompt is revealed at the event.</a:t>
+            </a:r>
+            <a:endParaRPr lang="en-US" dirty="0"/>
+          </a:p>
+        </p:txBody>
+      </p:sp>
+      <p:sp>
+        <p:nvSpPr>
+          <p:cNvPr id="4" name="Slide Number Placeholder 3"/>
+          <p:cNvSpPr>
+            <a:spLocks noGrp="1"/>
+          </p:cNvSpPr>
+          <p:nvPr>
+            <p:ph type="sldNum" sz="quarter" idx="10"/>
+          </p:nvPr>
+        </p:nvSpPr>
+        <p:spPr/>
+        <p:txBody>
+          <a:bodyPr/>
+          <a:lstStyle/>
+          <a:p>
+            <a:fld id="{F7021451-1387-4CA6-816F-3879F97B5CBC}" type="slidenum">
+              <a:rPr lang="en-US"/>
+              <a:t>10</a:t>
+            </a:fld>
+            <a:endParaRPr lang="en-US"/>
+          </a:p>
+        </p:txBody>
+      </p:sp>
+    </p:spTree>
+    <p:extLst>
+      <p:ext uri="{BB962C8B-B14F-4D97-AF65-F5344CB8AC3E}">
+        <p14:creationId xmlns:p14="http://schemas.microsoft.com/office/powerpoint/2010/main" val="1024086991"/>
+      </p:ext>
+    </p:extLst>
+  </p:cSld>
+  <p:clrMapOvr>
+    <a:masterClrMapping/>
+  </p:clrMapOvr>
+</p:notes>
+</file>
+
+<file path=ppt/notesSlides/notesSlide11.xml><?xml version="1.0" encoding="utf-8"?>
+<p:notes xmlns:a="http://schemas.openxmlformats.org/drawingml/2006/main" xmlns:r="http://schemas.openxmlformats.org/officeDocument/2006/relationships" xmlns:p="http://schemas.openxmlformats.org/presentationml/2006/main">
+  <p:cSld>
+    <p:spTree>
+      <p:nvGrpSpPr>
+        <p:cNvPr id="1" name=""/>
+        <p:cNvGrpSpPr/>
+        <p:nvPr/>
+      </p:nvGrpSpPr>
+      <p:grpSpPr>
+        <a:xfrm>
+          <a:off x="0" y="0"/>
+          <a:ext cx="0" cy="0"/>
+          <a:chOff x="0" y="0"/>
+          <a:chExt cx="0" cy="0"/>
+        </a:xfrm>
+      </p:grpSpPr>
+      <p:sp>
+        <p:nvSpPr>
+          <p:cNvPr id="2" name="Slide Image Placeholder 1"/>
+          <p:cNvSpPr>
+            <a:spLocks noGrp="1" noRot="1" noChangeAspect="1"/>
+          </p:cNvSpPr>
+          <p:nvPr>
+            <p:ph type="sldImg"/>
+          </p:nvPr>
+        </p:nvSpPr>
+        <p:spPr/>
+      </p:sp>
+      <p:sp>
+        <p:nvSpPr>
+          <p:cNvPr id="3" name="Notes Placeholder 2"/>
+          <p:cNvSpPr>
+            <a:spLocks noGrp="1"/>
+          </p:cNvSpPr>
+          <p:nvPr>
+            <p:ph type="body" idx="1"/>
+          </p:nvPr>
+        </p:nvSpPr>
+        <p:spPr/>
+        <p:txBody>
+          <a:bodyPr/>
+          <a:lstStyle/>
+          <a:p>
+            <a:r>
+              <a:rPr lang="en-US" dirty="0"/>
+              <a:t>Minutes 40–100. Ten minutes to choose the next ai-assistant increment, then fifty to build and verify. Staff circulate. The assistant build remains due October 6. The hackathon uses a supplied application, so no completed homework application is required that evening.</a:t>
+            </a:r>
+            <a:endParaRPr lang="en-US" dirty="0"/>
+          </a:p>
+        </p:txBody>
+      </p:sp>
+      <p:sp>
+        <p:nvSpPr>
+          <p:cNvPr id="4" name="Slide Number Placeholder 3"/>
+          <p:cNvSpPr>
+            <a:spLocks noGrp="1"/>
+          </p:cNvSpPr>
+          <p:nvPr>
+            <p:ph type="sldNum" sz="quarter" idx="10"/>
+          </p:nvPr>
+        </p:nvSpPr>
+        <p:spPr/>
+        <p:txBody>
+          <a:bodyPr/>
+          <a:lstStyle/>
+          <a:p>
+            <a:fld id="{F7021451-1387-4CA6-816F-3879F97B5CBC}" type="slidenum">
+              <a:rPr lang="en-US"/>
+              <a:t>11</a:t>
+            </a:fld>
+            <a:endParaRPr lang="en-US"/>
+          </a:p>
+        </p:txBody>
+      </p:sp>
+    </p:spTree>
+    <p:extLst>
+      <p:ext uri="{BB962C8B-B14F-4D97-AF65-F5344CB8AC3E}">
+        <p14:creationId xmlns:p14="http://schemas.microsoft.com/office/powerpoint/2010/main" val="1024086991"/>
+      </p:ext>
+    </p:extLst>
+  </p:cSld>
+  <p:clrMapOvr>
+    <a:masterClrMapping/>
+  </p:clrMapOvr>
+</p:notes>
+</file>
+
+<file path=ppt/notesSlides/notesSlide12.xml><?xml version="1.0" encoding="utf-8"?>
+<p:notes xmlns:a="http://schemas.openxmlformats.org/drawingml/2006/main" xmlns:r="http://schemas.openxmlformats.org/officeDocument/2006/relationships" xmlns:p="http://schemas.openxmlformats.org/presentationml/2006/main">
+  <p:cSld>
+    <p:spTree>
+      <p:nvGrpSpPr>
+        <p:cNvPr id="1" name=""/>
+        <p:cNvGrpSpPr/>
+        <p:nvPr/>
+      </p:nvGrpSpPr>
+      <p:grpSpPr>
+        <a:xfrm>
+          <a:off x="0" y="0"/>
+          <a:ext cx="0" cy="0"/>
+          <a:chOff x="0" y="0"/>
+          <a:chExt cx="0" cy="0"/>
+        </a:xfrm>
+      </p:grpSpPr>
+      <p:sp>
+        <p:nvSpPr>
+          <p:cNvPr id="2" name="Slide Image Placeholder 1"/>
+          <p:cNvSpPr>
+            <a:spLocks noGrp="1" noRot="1" noChangeAspect="1"/>
+          </p:cNvSpPr>
+          <p:nvPr>
+            <p:ph type="sldImg"/>
+          </p:nvPr>
+        </p:nvSpPr>
+        <p:spPr/>
+      </p:sp>
+      <p:sp>
+        <p:nvSpPr>
+          <p:cNvPr id="3" name="Notes Placeholder 2"/>
+          <p:cNvSpPr>
+            <a:spLocks noGrp="1"/>
+          </p:cNvSpPr>
+          <p:nvPr>
+            <p:ph type="body" idx="1"/>
+          </p:nvPr>
+        </p:nvSpPr>
+        <p:spPr/>
+        <p:txBody>
+          <a:bodyPr/>
+          <a:lstStyle/>
+          <a:p>
+            <a:r>
+              <a:rPr lang="en-US" dirty="0"/>
+              <a:t>Minutes 100–110. Preserve the supported-work close. No separate lab submission. Check the course announcement for hackathon logistics and model availability.</a:t>
+            </a:r>
+            <a:endParaRPr lang="en-US" dirty="0"/>
+          </a:p>
+        </p:txBody>
+      </p:sp>
+      <p:sp>
+        <p:nvSpPr>
+          <p:cNvPr id="4" name="Slide Number Placeholder 3"/>
+          <p:cNvSpPr>
+            <a:spLocks noGrp="1"/>
+          </p:cNvSpPr>
+          <p:nvPr>
+            <p:ph type="sldNum" sz="quarter" idx="10"/>
+          </p:nvPr>
+        </p:nvSpPr>
+        <p:spPr/>
+        <p:txBody>
+          <a:bodyPr/>
+          <a:lstStyle/>
+          <a:p>
+            <a:fld id="{F7021451-1387-4CA6-816F-3879F97B5CBC}" type="slidenum">
+              <a:rPr lang="en-US"/>
+              <a:t>12</a:t>
+            </a:fld>
+            <a:endParaRPr lang="en-US"/>
+          </a:p>
+        </p:txBody>
+      </p:sp>
+    </p:spTree>
+    <p:extLst>
+      <p:ext uri="{BB962C8B-B14F-4D97-AF65-F5344CB8AC3E}">
+        <p14:creationId xmlns:p14="http://schemas.microsoft.com/office/powerpoint/2010/main" val="1024086991"/>
+      </p:ext>
+    </p:extLst>
+  </p:cSld>
+  <p:clrMapOvr>
+    <a:masterClrMapping/>
+  </p:clrMapOvr>
+</p:notes>
+</file>
+
 <file path=ppt/notesSlides/notesSlide2.xml><?xml version="1.0" encoding="utf-8"?>
 <p:notes xmlns:a="http://schemas.openxmlformats.org/drawingml/2006/main" xmlns:r="http://schemas.openxmlformats.org/officeDocument/2006/relationships" xmlns:p="http://schemas.openxmlformats.org/presentationml/2006/main">
   <p:cSld>
@@ -597,7 +865,7 @@
           <a:p>
             <a:r>
               <a:rPr lang="en-US" dirty="0"/>
-              <a:t>Ten-minute intake. If design is incomplete, finish it before application implementation.</a:t>
+              <a:t>Minutes 0–5. Open the ordinary inventory functions. Storage and quantity checks already work. The user has not told us whether sharing is acceptable. Do not reveal the real hackathon domain.</a:t>
             </a:r>
             <a:endParaRPr lang="en-US" dirty="0"/>
           </a:p>
@@ -685,7 +953,7 @@
           <a:p>
             <a:r>
               <a:rPr lang="en-US" dirty="0"/>
-              <a:t>Staff circulate during the long work block. Do not prescribe module names.</a:t>
+              <a:t>Minutes 5–9. Compare both approaches. A plan-first system can also continue after observations; it is not inherently wrong. Ask students which information would change a decision. More calls are not evidence of a better design.</a:t>
             </a:r>
             <a:endParaRPr lang="en-US" dirty="0"/>
           </a:p>
@@ -773,7 +1041,7 @@
           <a:p>
             <a:r>
               <a:rPr lang="en-US" dirty="0"/>
-              <a:t>Ask for a plausible defect each assertion would catch.</a:t>
+              <a:t>Minutes 9–13. Open design/SYSTEM.md and FLOW.md. Point to a rejected alternative. The example owns its boundaries; students will choose theirs in the assessment. The reset history is supplied example history, not evidence of a student design process.</a:t>
             </a:r>
             <a:endParaRPr lang="en-US" dirty="0"/>
           </a:p>
@@ -861,7 +1129,7 @@
           <a:p>
             <a:r>
               <a:rPr lang="en-US" dirty="0"/>
-              <a:t>Minutes 80–100. No live-model requirement for safety checks. Do not touch the development repository.</a:t>
+              <a:t>Minutes 13–15. Open categorize. It performs one bounded prompt and ordinary validation. The model does not choose the next operation. In the agent, the next operation depends on observations.</a:t>
             </a:r>
             <a:endParaRPr lang="en-US" dirty="0"/>
           </a:p>
@@ -949,7 +1217,7 @@
           <a:p>
             <a:r>
               <a:rPr lang="en-US" dirty="0"/>
-              <a:t>Use fake transport for deterministic configuration checks. Aider and the application have separate YAML settings.</a:t>
+              <a:t>Minutes 15–18. Description and argument contract make a capability visible; validation and dispatch actually invoke it. Open dispatch. This example uses text JSON; native function calling is another valid protocol. The model does not execute Python.</a:t>
             </a:r>
             <a:endParaRPr lang="en-US" dirty="0"/>
           </a:p>
@@ -1037,7 +1305,7 @@
           <a:p>
             <a:r>
               <a:rPr lang="en-US" dirty="0"/>
-              <a:t>Last ten minutes. Independent missing artifacts still lose their own points.</a:t>
+              <a:t>Minutes 18–30. Open the exercise. The missing observation causes two tests to fail. Commit the increment specification before implementation. Keep the model context small. If live editing stalls, compare the worked solution and preserve the timebox.</a:t>
             </a:r>
             <a:endParaRPr lang="en-US" dirty="0"/>
           </a:p>
@@ -1125,7 +1393,7 @@
           <a:p>
             <a:r>
               <a:rPr lang="en-US" dirty="0"/>
-              <a:t>The complete rubric and acceptance scenarios are in the student repository. Confirm event logistics through the course announcement.</a:t>
+              <a:t>Minutes 30–33. Use the rehearsed live example or the scripted fallback. Label the fallback prominently: these are test responses, not evidence of a live model solve. The failed action must enter the next request automatically.</a:t>
             </a:r>
             <a:endParaRPr lang="en-US" dirty="0"/>
           </a:p>
@@ -1149,6 +1417,94 @@
             <a:fld id="{F7021451-1387-4CA6-816F-3879F97B5CBC}" type="slidenum">
               <a:rPr lang="en-US"/>
               <a:t>8</a:t>
+            </a:fld>
+            <a:endParaRPr lang="en-US"/>
+          </a:p>
+        </p:txBody>
+      </p:sp>
+    </p:spTree>
+    <p:extLst>
+      <p:ext uri="{BB962C8B-B14F-4D97-AF65-F5344CB8AC3E}">
+        <p14:creationId xmlns:p14="http://schemas.microsoft.com/office/powerpoint/2010/main" val="1024086991"/>
+      </p:ext>
+    </p:extLst>
+  </p:cSld>
+  <p:clrMapOvr>
+    <a:masterClrMapping/>
+  </p:clrMapOvr>
+</p:notes>
+</file>
+
+<file path=ppt/notesSlides/notesSlide9.xml><?xml version="1.0" encoding="utf-8"?>
+<p:notes xmlns:a="http://schemas.openxmlformats.org/drawingml/2006/main" xmlns:r="http://schemas.openxmlformats.org/officeDocument/2006/relationships" xmlns:p="http://schemas.openxmlformats.org/presentationml/2006/main">
+  <p:cSld>
+    <p:spTree>
+      <p:nvGrpSpPr>
+        <p:cNvPr id="1" name=""/>
+        <p:cNvGrpSpPr/>
+        <p:nvPr/>
+      </p:nvGrpSpPr>
+      <p:grpSpPr>
+        <a:xfrm>
+          <a:off x="0" y="0"/>
+          <a:ext cx="0" cy="0"/>
+          <a:chOff x="0" y="0"/>
+          <a:chExt cx="0" cy="0"/>
+        </a:xfrm>
+      </p:grpSpPr>
+      <p:sp>
+        <p:nvSpPr>
+          <p:cNvPr id="2" name="Slide Image Placeholder 1"/>
+          <p:cNvSpPr>
+            <a:spLocks noGrp="1" noRot="1" noChangeAspect="1"/>
+          </p:cNvSpPr>
+          <p:nvPr>
+            <p:ph type="sldImg"/>
+          </p:nvPr>
+        </p:nvSpPr>
+        <p:spPr/>
+      </p:sp>
+      <p:sp>
+        <p:nvSpPr>
+          <p:cNvPr id="3" name="Notes Placeholder 2"/>
+          <p:cNvSpPr>
+            <a:spLocks noGrp="1"/>
+          </p:cNvSpPr>
+          <p:nvPr>
+            <p:ph type="body" idx="1"/>
+          </p:nvPr>
+        </p:nvSpPr>
+        <p:spPr/>
+        <p:txBody>
+          <a:bodyPr/>
+          <a:lstStyle/>
+          <a:p>
+            <a:r>
+              <a:rPr lang="en-US" dirty="0"/>
+              <a:t>Minutes 33–36. Inspect inventory.json and the tests. A confident final sentence does not establish a reservation. Ask whether approval should happen before or after checking availability. This is a design question, not merely more defensive code.</a:t>
+            </a:r>
+            <a:endParaRPr lang="en-US" dirty="0"/>
+          </a:p>
+        </p:txBody>
+      </p:sp>
+      <p:sp>
+        <p:nvSpPr>
+          <p:cNvPr id="4" name="Slide Number Placeholder 3"/>
+          <p:cNvSpPr>
+            <a:spLocks noGrp="1"/>
+          </p:cNvSpPr>
+          <p:nvPr>
+            <p:ph type="sldNum" sz="quarter" idx="10"/>
+          </p:nvPr>
+        </p:nvSpPr>
+        <p:spPr/>
+        <p:txBody>
+          <a:bodyPr/>
+          <a:lstStyle/>
+          <a:p>
+            <a:fld id="{F7021451-1387-4CA6-816F-3879F97B5CBC}" type="slidenum">
+              <a:rPr lang="en-US"/>
+              <a:t>9</a:t>
             </a:fld>
             <a:endParaRPr lang="en-US"/>
           </a:p>
@@ -1513,6 +1869,123 @@
 </p:sld>
 </file>
 
+<file path=ppt/slides/slide10.xml><?xml version="1.0" encoding="utf-8"?>
+<p:sld xmlns:a="http://schemas.openxmlformats.org/drawingml/2006/main" xmlns:r="http://schemas.openxmlformats.org/officeDocument/2006/relationships" xmlns:p="http://schemas.openxmlformats.org/presentationml/2006/main">
+  <p:cSld name="Slide 10">
+    <p:bg>
+      <p:bgPr>
+        <a:blipFill dpi="0" rotWithShape="1">
+          <a:blip r:embed="rId1">
+            <a:lum/>
+          </a:blip>
+          <a:srcRect/>
+          <a:stretch>
+            <a:fillRect/>
+          </a:stretch>
+        </a:blipFill>
+        <a:effectLst/>
+      </p:bgPr>
+    </p:bg>
+    <p:spTree>
+      <p:nvGrpSpPr>
+        <p:cNvPr id="1" name=""/>
+        <p:cNvGrpSpPr/>
+        <p:nvPr/>
+      </p:nvGrpSpPr>
+      <p:grpSpPr>
+        <a:xfrm>
+          <a:off x="0" y="0"/>
+          <a:ext cx="0" cy="0"/>
+          <a:chOff x="0" y="0"/>
+          <a:chExt cx="0" cy="0"/>
+        </a:xfrm>
+      </p:grpSpPr>
+    </p:spTree>
+  </p:cSld>
+  <p:clrMapOvr>
+    <a:masterClrMapping/>
+  </p:clrMapOvr>
+</p:sld>
+</file>
+
+<file path=ppt/slides/slide11.xml><?xml version="1.0" encoding="utf-8"?>
+<p:sld xmlns:a="http://schemas.openxmlformats.org/drawingml/2006/main" xmlns:r="http://schemas.openxmlformats.org/officeDocument/2006/relationships" xmlns:p="http://schemas.openxmlformats.org/presentationml/2006/main">
+  <p:cSld name="Slide 11">
+    <p:bg>
+      <p:bgPr>
+        <a:blipFill dpi="0" rotWithShape="1">
+          <a:blip r:embed="rId1">
+            <a:lum/>
+          </a:blip>
+          <a:srcRect/>
+          <a:stretch>
+            <a:fillRect/>
+          </a:stretch>
+        </a:blipFill>
+        <a:effectLst/>
+      </p:bgPr>
+    </p:bg>
+    <p:spTree>
+      <p:nvGrpSpPr>
+        <p:cNvPr id="1" name=""/>
+        <p:cNvGrpSpPr/>
+        <p:nvPr/>
+      </p:nvGrpSpPr>
+      <p:grpSpPr>
+        <a:xfrm>
+          <a:off x="0" y="0"/>
+          <a:ext cx="0" cy="0"/>
+          <a:chOff x="0" y="0"/>
+          <a:chExt cx="0" cy="0"/>
+        </a:xfrm>
+      </p:grpSpPr>
+    </p:spTree>
+  </p:cSld>
+  <p:clrMapOvr>
+    <a:masterClrMapping/>
+  </p:clrMapOvr>
+</p:sld>
+</file>
+
+<file path=ppt/slides/slide12.xml><?xml version="1.0" encoding="utf-8"?>
+<p:sld xmlns:a="http://schemas.openxmlformats.org/drawingml/2006/main" xmlns:r="http://schemas.openxmlformats.org/officeDocument/2006/relationships" xmlns:p="http://schemas.openxmlformats.org/presentationml/2006/main">
+  <p:cSld name="Slide 12">
+    <p:bg>
+      <p:bgPr>
+        <a:blipFill dpi="0" rotWithShape="1">
+          <a:blip r:embed="rId1">
+            <a:lum/>
+          </a:blip>
+          <a:srcRect/>
+          <a:stretch>
+            <a:fillRect/>
+          </a:stretch>
+        </a:blipFill>
+        <a:effectLst/>
+      </p:bgPr>
+    </p:bg>
+    <p:spTree>
+      <p:nvGrpSpPr>
+        <p:cNvPr id="1" name=""/>
+        <p:cNvGrpSpPr/>
+        <p:nvPr/>
+      </p:nvGrpSpPr>
+      <p:grpSpPr>
+        <a:xfrm>
+          <a:off x="0" y="0"/>
+          <a:ext cx="0" cy="0"/>
+          <a:chOff x="0" y="0"/>
+          <a:chExt cx="0" cy="0"/>
+        </a:xfrm>
+      </p:grpSpPr>
+    </p:spTree>
+  </p:cSld>
+  <p:clrMapOvr>
+    <a:masterClrMapping/>
+  </p:clrMapOvr>
+</p:sld>
+</file>
+
 <file path=ppt/slides/slide2.xml><?xml version="1.0" encoding="utf-8"?>
 <p:sld xmlns:a="http://schemas.openxmlformats.org/drawingml/2006/main" xmlns:r="http://schemas.openxmlformats.org/officeDocument/2006/relationships" xmlns:p="http://schemas.openxmlformats.org/presentationml/2006/main">
   <p:cSld name="Slide 2">
@@ -1750,6 +2223,45 @@
 <file path=ppt/slides/slide8.xml><?xml version="1.0" encoding="utf-8"?>
 <p:sld xmlns:a="http://schemas.openxmlformats.org/drawingml/2006/main" xmlns:r="http://schemas.openxmlformats.org/officeDocument/2006/relationships" xmlns:p="http://schemas.openxmlformats.org/presentationml/2006/main">
   <p:cSld name="Slide 8">
+    <p:bg>
+      <p:bgPr>
+        <a:blipFill dpi="0" rotWithShape="1">
+          <a:blip r:embed="rId1">
+            <a:lum/>
+          </a:blip>
+          <a:srcRect/>
+          <a:stretch>
+            <a:fillRect/>
+          </a:stretch>
+        </a:blipFill>
+        <a:effectLst/>
+      </p:bgPr>
+    </p:bg>
+    <p:spTree>
+      <p:nvGrpSpPr>
+        <p:cNvPr id="1" name=""/>
+        <p:cNvGrpSpPr/>
+        <p:nvPr/>
+      </p:nvGrpSpPr>
+      <p:grpSpPr>
+        <a:xfrm>
+          <a:off x="0" y="0"/>
+          <a:ext cx="0" cy="0"/>
+          <a:chOff x="0" y="0"/>
+          <a:chExt cx="0" cy="0"/>
+        </a:xfrm>
+      </p:grpSpPr>
+    </p:spTree>
+  </p:cSld>
+  <p:clrMapOvr>
+    <a:masterClrMapping/>
+  </p:clrMapOvr>
+</p:sld>
+</file>
+
+<file path=ppt/slides/slide9.xml><?xml version="1.0" encoding="utf-8"?>
+<p:sld xmlns:a="http://schemas.openxmlformats.org/drawingml/2006/main" xmlns:r="http://schemas.openxmlformats.org/officeDocument/2006/relationships" xmlns:p="http://schemas.openxmlformats.org/presentationml/2006/main">
+  <p:cSld name="Slide 9">
     <p:bg>
       <p:bgPr>
         <a:blipFill dpi="0" rotWithShape="1">

</xml_diff>